<commit_message>
updated project image background colour
</commit_message>
<xml_diff>
--- a/docs/assets/logo.pptx
+++ b/docs/assets/logo.pptx
@@ -9,6 +9,7 @@
     <p:sldId id="257" r:id="rId3"/>
     <p:sldId id="258" r:id="rId4"/>
     <p:sldId id="259" r:id="rId5"/>
+    <p:sldId id="260" r:id="rId6"/>
   </p:sldIdLst>
   <p:sldSz cx="12192000" cy="6858000"/>
   <p:notesSz cx="6858000" cy="9144000"/>
@@ -107,6 +108,11 @@
       </a:defRPr>
     </a:lvl9pPr>
   </p:defaultTextStyle>
+  <p:extLst>
+    <p:ext uri="{EFAFB233-063F-42B5-8137-9DF3F51BA10A}">
+      <p15:sldGuideLst xmlns:p15="http://schemas.microsoft.com/office/powerpoint/2012/main"/>
+    </p:ext>
+  </p:extLst>
 </p:presentation>
 </file>
 
@@ -257,7 +263,7 @@
           <a:p>
             <a:fld id="{45C9D0FF-0F05-4DB4-9311-7D04CC070DFA}" type="datetimeFigureOut">
               <a:rPr lang="en-US" smtClean="0"/>
-              <a:t>5/11/2026</a:t>
+              <a:t>5/13/2026</a:t>
             </a:fld>
             <a:endParaRPr lang="en-US"/>
           </a:p>
@@ -455,7 +461,7 @@
           <a:p>
             <a:fld id="{45C9D0FF-0F05-4DB4-9311-7D04CC070DFA}" type="datetimeFigureOut">
               <a:rPr lang="en-US" smtClean="0"/>
-              <a:t>5/11/2026</a:t>
+              <a:t>5/13/2026</a:t>
             </a:fld>
             <a:endParaRPr lang="en-US"/>
           </a:p>
@@ -663,7 +669,7 @@
           <a:p>
             <a:fld id="{45C9D0FF-0F05-4DB4-9311-7D04CC070DFA}" type="datetimeFigureOut">
               <a:rPr lang="en-US" smtClean="0"/>
-              <a:t>5/11/2026</a:t>
+              <a:t>5/13/2026</a:t>
             </a:fld>
             <a:endParaRPr lang="en-US"/>
           </a:p>
@@ -861,7 +867,7 @@
           <a:p>
             <a:fld id="{45C9D0FF-0F05-4DB4-9311-7D04CC070DFA}" type="datetimeFigureOut">
               <a:rPr lang="en-US" smtClean="0"/>
-              <a:t>5/11/2026</a:t>
+              <a:t>5/13/2026</a:t>
             </a:fld>
             <a:endParaRPr lang="en-US"/>
           </a:p>
@@ -1136,7 +1142,7 @@
           <a:p>
             <a:fld id="{45C9D0FF-0F05-4DB4-9311-7D04CC070DFA}" type="datetimeFigureOut">
               <a:rPr lang="en-US" smtClean="0"/>
-              <a:t>5/11/2026</a:t>
+              <a:t>5/13/2026</a:t>
             </a:fld>
             <a:endParaRPr lang="en-US"/>
           </a:p>
@@ -1401,7 +1407,7 @@
           <a:p>
             <a:fld id="{45C9D0FF-0F05-4DB4-9311-7D04CC070DFA}" type="datetimeFigureOut">
               <a:rPr lang="en-US" smtClean="0"/>
-              <a:t>5/11/2026</a:t>
+              <a:t>5/13/2026</a:t>
             </a:fld>
             <a:endParaRPr lang="en-US"/>
           </a:p>
@@ -1813,7 +1819,7 @@
           <a:p>
             <a:fld id="{45C9D0FF-0F05-4DB4-9311-7D04CC070DFA}" type="datetimeFigureOut">
               <a:rPr lang="en-US" smtClean="0"/>
-              <a:t>5/11/2026</a:t>
+              <a:t>5/13/2026</a:t>
             </a:fld>
             <a:endParaRPr lang="en-US"/>
           </a:p>
@@ -1954,7 +1960,7 @@
           <a:p>
             <a:fld id="{45C9D0FF-0F05-4DB4-9311-7D04CC070DFA}" type="datetimeFigureOut">
               <a:rPr lang="en-US" smtClean="0"/>
-              <a:t>5/11/2026</a:t>
+              <a:t>5/13/2026</a:t>
             </a:fld>
             <a:endParaRPr lang="en-US"/>
           </a:p>
@@ -2067,7 +2073,7 @@
           <a:p>
             <a:fld id="{45C9D0FF-0F05-4DB4-9311-7D04CC070DFA}" type="datetimeFigureOut">
               <a:rPr lang="en-US" smtClean="0"/>
-              <a:t>5/11/2026</a:t>
+              <a:t>5/13/2026</a:t>
             </a:fld>
             <a:endParaRPr lang="en-US"/>
           </a:p>
@@ -2378,7 +2384,7 @@
           <a:p>
             <a:fld id="{45C9D0FF-0F05-4DB4-9311-7D04CC070DFA}" type="datetimeFigureOut">
               <a:rPr lang="en-US" smtClean="0"/>
-              <a:t>5/11/2026</a:t>
+              <a:t>5/13/2026</a:t>
             </a:fld>
             <a:endParaRPr lang="en-US"/>
           </a:p>
@@ -2666,7 +2672,7 @@
           <a:p>
             <a:fld id="{45C9D0FF-0F05-4DB4-9311-7D04CC070DFA}" type="datetimeFigureOut">
               <a:rPr lang="en-US" smtClean="0"/>
-              <a:t>5/11/2026</a:t>
+              <a:t>5/13/2026</a:t>
             </a:fld>
             <a:endParaRPr lang="en-US"/>
           </a:p>
@@ -2907,7 +2913,7 @@
           <a:p>
             <a:fld id="{45C9D0FF-0F05-4DB4-9311-7D04CC070DFA}" type="datetimeFigureOut">
               <a:rPr lang="en-US" smtClean="0"/>
-              <a:t>5/11/2026</a:t>
+              <a:t>5/13/2026</a:t>
             </a:fld>
             <a:endParaRPr lang="en-US"/>
           </a:p>
@@ -4264,7 +4270,11 @@
             <a:lstStyle/>
             <a:p>
               <a:pPr algn="ctr"/>
-              <a:endParaRPr lang="en-US"/>
+              <a:endParaRPr lang="en-US">
+                <a:solidFill>
+                  <a:srgbClr val="8C54FE"/>
+                </a:solidFill>
+              </a:endParaRPr>
             </a:p>
           </p:txBody>
         </p:sp>
@@ -4316,7 +4326,11 @@
             <a:lstStyle/>
             <a:p>
               <a:pPr algn="ctr"/>
-              <a:endParaRPr lang="en-US"/>
+              <a:endParaRPr lang="en-US">
+                <a:solidFill>
+                  <a:srgbClr val="E497FF"/>
+                </a:solidFill>
+              </a:endParaRPr>
             </a:p>
           </p:txBody>
         </p:sp>
@@ -4472,7 +4486,11 @@
             <a:lstStyle/>
             <a:p>
               <a:pPr algn="ctr"/>
-              <a:endParaRPr lang="en-US"/>
+              <a:endParaRPr lang="en-US">
+                <a:solidFill>
+                  <a:srgbClr val="AF67FF"/>
+                </a:solidFill>
+              </a:endParaRPr>
             </a:p>
           </p:txBody>
         </p:sp>
@@ -5201,7 +5219,11 @@
           <a:lstStyle/>
           <a:p>
             <a:pPr algn="ctr"/>
-            <a:endParaRPr lang="en-US"/>
+            <a:endParaRPr lang="en-US">
+              <a:solidFill>
+                <a:srgbClr val="70A3F9"/>
+              </a:solidFill>
+            </a:endParaRPr>
           </a:p>
         </p:txBody>
       </p:sp>
@@ -5461,7 +5483,11 @@
           <a:lstStyle/>
           <a:p>
             <a:pPr algn="ctr"/>
-            <a:endParaRPr lang="en-US"/>
+            <a:endParaRPr lang="en-US">
+              <a:solidFill>
+                <a:srgbClr val="A3C5FB"/>
+              </a:solidFill>
+            </a:endParaRPr>
           </a:p>
         </p:txBody>
       </p:sp>
@@ -5617,7 +5643,11 @@
           <a:lstStyle/>
           <a:p>
             <a:pPr algn="ctr"/>
-            <a:endParaRPr lang="en-US"/>
+            <a:endParaRPr lang="en-US">
+              <a:solidFill>
+                <a:srgbClr val="D7E5FD"/>
+              </a:solidFill>
+            </a:endParaRPr>
           </a:p>
         </p:txBody>
       </p:sp>
@@ -6544,8 +6574,8 @@
           </p:nvSpPr>
           <p:spPr>
             <a:xfrm rot="20021161">
-              <a:off x="5058321" y="1725714"/>
-              <a:ext cx="445230" cy="392876"/>
+              <a:off x="5052573" y="1725944"/>
+              <a:ext cx="446270" cy="392876"/>
             </a:xfrm>
             <a:prstGeom prst="rect">
               <a:avLst/>
@@ -7064,8 +7094,8 @@
           </p:nvSpPr>
           <p:spPr>
             <a:xfrm>
-              <a:off x="4994310" y="1866900"/>
-              <a:ext cx="371475" cy="3569213"/>
+              <a:off x="4994310" y="1862962"/>
+              <a:ext cx="371475" cy="3573152"/>
             </a:xfrm>
             <a:prstGeom prst="rect">
               <a:avLst/>
@@ -7480,8 +7510,8 @@
           </p:nvSpPr>
           <p:spPr>
             <a:xfrm>
-              <a:off x="4623431" y="1898774"/>
-              <a:ext cx="371475" cy="1038855"/>
+              <a:off x="4621050" y="1862961"/>
+              <a:ext cx="371475" cy="1074667"/>
             </a:xfrm>
             <a:prstGeom prst="rect">
               <a:avLst/>
@@ -7635,6 +7665,72 @@
     <p:extLst>
       <p:ext uri="{BB962C8B-B14F-4D97-AF65-F5344CB8AC3E}">
         <p14:creationId xmlns:p14="http://schemas.microsoft.com/office/powerpoint/2010/main" val="199743630"/>
+      </p:ext>
+    </p:extLst>
+  </p:cSld>
+  <p:clrMapOvr>
+    <a:masterClrMapping/>
+  </p:clrMapOvr>
+</p:sld>
+</file>
+
+<file path=ppt/slides/slide5.xml><?xml version="1.0" encoding="utf-8"?>
+<p:sld xmlns:a="http://schemas.openxmlformats.org/drawingml/2006/main" xmlns:r="http://schemas.openxmlformats.org/officeDocument/2006/relationships" xmlns:p="http://schemas.openxmlformats.org/presentationml/2006/main">
+  <p:cSld>
+    <p:spTree>
+      <p:nvGrpSpPr>
+        <p:cNvPr id="1" name="">
+          <a:extLst>
+            <a:ext uri="{FF2B5EF4-FFF2-40B4-BE49-F238E27FC236}">
+              <a16:creationId xmlns:a16="http://schemas.microsoft.com/office/drawing/2014/main" id="{3E1EC2B7-4ABC-9CD2-9BBE-320489456EA2}"/>
+            </a:ext>
+          </a:extLst>
+        </p:cNvPr>
+        <p:cNvGrpSpPr/>
+        <p:nvPr/>
+      </p:nvGrpSpPr>
+      <p:grpSpPr>
+        <a:xfrm>
+          <a:off x="0" y="0"/>
+          <a:ext cx="0" cy="0"/>
+          <a:chOff x="0" y="0"/>
+          <a:chExt cx="0" cy="0"/>
+        </a:xfrm>
+      </p:grpSpPr>
+      <p:pic>
+        <p:nvPicPr>
+          <p:cNvPr id="5" name="Picture 4">
+            <a:extLst>
+              <a:ext uri="{FF2B5EF4-FFF2-40B4-BE49-F238E27FC236}">
+                <a16:creationId xmlns:a16="http://schemas.microsoft.com/office/drawing/2014/main" id="{F5E44CFB-3AEB-E1E2-1B53-961FB3165ADC}"/>
+              </a:ext>
+            </a:extLst>
+          </p:cNvPr>
+          <p:cNvPicPr>
+            <a:picLocks noChangeAspect="1"/>
+          </p:cNvPicPr>
+          <p:nvPr/>
+        </p:nvPicPr>
+        <p:blipFill>
+          <a:blip r:embed="rId2"/>
+          <a:stretch>
+            <a:fillRect/>
+          </a:stretch>
+        </p:blipFill>
+        <p:spPr>
+          <a:xfrm>
+            <a:off x="3737838" y="202968"/>
+            <a:ext cx="4376259" cy="6452063"/>
+          </a:xfrm>
+          <a:prstGeom prst="rect">
+            <a:avLst/>
+          </a:prstGeom>
+        </p:spPr>
+      </p:pic>
+    </p:spTree>
+    <p:extLst>
+      <p:ext uri="{BB962C8B-B14F-4D97-AF65-F5344CB8AC3E}">
+        <p14:creationId xmlns:p14="http://schemas.microsoft.com/office/powerpoint/2010/main" val="265107196"/>
       </p:ext>
     </p:extLst>
   </p:cSld>

</xml_diff>